<commit_message>
System Design vi: sd-10-024 SHA-256 va Java mang so, deck va PPTX theo bai
Co-Authored-By: Claude Sonnet 5.5 <noreply@anthropic.com>
Claude-Session: https://claude.ai/code/session_01JJCRKgpbfdpiPMwgBVozBY
</commit_message>
<xml_diff>
--- a/system-design-101/vi/lessons/sd-10-024/slides/sd-10-024.pptx
+++ b/system-design-101/vi/lessons/sd-10-024/slides/sd-10-024.pptx
@@ -6786,7 +6786,18 @@
                 <a:ea typeface="Be Vietnam Pro" pitchFamily="34" charset="-122"/>
                 <a:cs typeface="Be Vietnam Pro" pitchFamily="34" charset="-120"/>
               </a:rPr>
-              <a:t>Java:</a:t>
+              <a:t>Java,</a:t>
+            </a:r>
+            <a:r>
+              <a:rPr lang="en-US" sz="2100" dirty="0" spc="-1" kern="0">
+                <a:solidFill>
+                  <a:srgbClr val="C4C8D6"/>
+                </a:solidFill>
+                <a:latin typeface="Be Vietnam Pro" pitchFamily="34" charset="0"/>
+                <a:ea typeface="Be Vietnam Pro" pitchFamily="34" charset="-122"/>
+                <a:cs typeface="Be Vietnam Pro" pitchFamily="34" charset="-120"/>
+              </a:rPr>
+              <a:t> mảng</a:t>
             </a:r>
             <a:r>
               <a:rPr lang="en-US" sz="2100" dirty="0" spc="-6" kern="0">
@@ -6797,18 +6808,7 @@
                 <a:ea typeface="Be Vietnam Pro" pitchFamily="34" charset="-122"/>
                 <a:cs typeface="Be Vietnam Pro" pitchFamily="34" charset="-120"/>
               </a:rPr>
-              <a:t> Dual-Pivot</a:t>
-            </a:r>
-            <a:r>
-              <a:rPr lang="en-US" sz="2100" dirty="0" spc="-5" kern="0">
-                <a:solidFill>
-                  <a:srgbClr val="C4C8D6"/>
-                </a:solidFill>
-                <a:latin typeface="Be Vietnam Pro" pitchFamily="34" charset="0"/>
-                <a:ea typeface="Be Vietnam Pro" pitchFamily="34" charset="-122"/>
-                <a:cs typeface="Be Vietnam Pro" pitchFamily="34" charset="-120"/>
-              </a:rPr>
-              <a:t> Quicksort</a:t>
+              <a:t> số: Dual-Pivot Quicksort</a:t>
             </a:r>
             <a:endParaRPr lang="en-US" sz="2100" dirty="0"/>
           </a:p>
@@ -11594,15 +11594,15 @@
               <a:t>Băm</a:t>
             </a:r>
             <a:r>
-              <a:rPr lang="en-US" sz="2250" b="1" dirty="0" spc="2" kern="0">
-                <a:solidFill>
-                  <a:srgbClr val="14161C"/>
-                </a:solidFill>
-                <a:latin typeface="Be Vietnam Pro" pitchFamily="34" charset="0"/>
-                <a:ea typeface="Be Vietnam Pro" pitchFamily="34" charset="-122"/>
-                <a:cs typeface="Be Vietnam Pro" pitchFamily="34" charset="-120"/>
-              </a:rPr>
-              <a:t> SHA</a:t>
+              <a:rPr lang="en-US" sz="2250" b="1" dirty="0" spc="0" kern="0">
+                <a:solidFill>
+                  <a:srgbClr val="14161C"/>
+                </a:solidFill>
+                <a:latin typeface="Be Vietnam Pro" pitchFamily="34" charset="0"/>
+                <a:ea typeface="Be Vietnam Pro" pitchFamily="34" charset="-122"/>
+                <a:cs typeface="Be Vietnam Pro" pitchFamily="34" charset="-120"/>
+              </a:rPr>
+              <a:t> SHA-256</a:t>
             </a:r>
             <a:endParaRPr lang="en-US" sz="2250" dirty="0"/>
           </a:p>

</xml_diff>

<commit_message>
System Design vi: sd-10-024 bay phep thu, sd-10-025 luong thay phien, deck va PPTX
Co-Authored-By: Claude Sonnet 5.5 <noreply@anthropic.com>
Claude-Session: https://claude.ai/code/session_01JJCRKgpbfdpiPMwgBVozBY
</commit_message>
<xml_diff>
--- a/system-design-101/vi/lessons/sd-10-024/slides/sd-10-024.pptx
+++ b/system-design-101/vi/lessons/sd-10-024/slides/sd-10-024.pptx
@@ -3247,18 +3247,7 @@
                 <a:ea typeface="Be Vietnam Pro" pitchFamily="34" charset="-122"/>
                 <a:cs typeface="Be Vietnam Pro" pitchFamily="34" charset="-120"/>
               </a:rPr>
-              <a:t> tên,</a:t>
-            </a:r>
-            <a:r>
-              <a:rPr lang="en-US" sz="3000" dirty="0" spc="0" kern="0">
-                <a:solidFill>
-                  <a:srgbClr val="C4C8D6"/>
-                </a:solidFill>
-                <a:latin typeface="Be Vietnam Pro" pitchFamily="34" charset="0"/>
-                <a:ea typeface="Be Vietnam Pro" pitchFamily="34" charset="-122"/>
-                <a:cs typeface="Be Vietnam Pro" pitchFamily="34" charset="-120"/>
-              </a:rPr>
-              <a:t> chín</a:t>
+              <a:t> tên, bảy</a:t>
             </a:r>
             <a:r>
               <a:rPr lang="en-US" sz="3000" dirty="0" spc="3" kern="0">

</xml_diff>

<commit_message>
Slides: sd-10-024 slide 3 noi ro ba ten cua nhom, PPTX
Co-Authored-By: Claude Sonnet 5.5 <noreply@anthropic.com>
Claude-Session: https://claude.ai/code/session_01JJCRKgpbfdpiPMwgBVozBY
</commit_message>
<xml_diff>
--- a/system-design-101/vi/lessons/sd-10-024/slides/sd-10-024.pptx
+++ b/system-design-101/vi/lessons/sd-10-024/slides/sd-10-024.pptx
@@ -6264,6 +6264,39 @@
               <a:buNone/>
             </a:pPr>
             <a:r>
+              <a:rPr lang="en-US" sz="2550" dirty="0" spc="2" kern="0">
+                <a:solidFill>
+                  <a:srgbClr val="F3EEE3"/>
+                </a:solidFill>
+                <a:latin typeface="Be Vietnam Pro" pitchFamily="34" charset="0"/>
+                <a:ea typeface="Be Vietnam Pro" pitchFamily="34" charset="-122"/>
+                <a:cs typeface="Be Vietnam Pro" pitchFamily="34" charset="-120"/>
+              </a:rPr>
+              <a:t>Cả</a:t>
+            </a:r>
+            <a:r>
+              <a:rPr lang="en-US" sz="2550" dirty="0" spc="-5" kern="0">
+                <a:solidFill>
+                  <a:srgbClr val="F3EEE3"/>
+                </a:solidFill>
+                <a:latin typeface="Be Vietnam Pro" pitchFamily="34" charset="0"/>
+                <a:ea typeface="Be Vietnam Pro" pitchFamily="34" charset="-122"/>
+                <a:cs typeface="Be Vietnam Pro" pitchFamily="34" charset="-120"/>
+              </a:rPr>
+              <a:t> ba</a:t>
+            </a:r>
+            <a:r>
+              <a:rPr lang="en-US" sz="2550" dirty="0" spc="-11" kern="0">
+                <a:solidFill>
+                  <a:srgbClr val="F3EEE3"/>
+                </a:solidFill>
+                <a:latin typeface="Be Vietnam Pro" pitchFamily="34" charset="0"/>
+                <a:ea typeface="Be Vietnam Pro" pitchFamily="34" charset="-122"/>
+                <a:cs typeface="Be Vietnam Pro" pitchFamily="34" charset="-120"/>
+              </a:rPr>
+              <a:t> tên</a:t>
+            </a:r>
+            <a:r>
               <a:rPr lang="en-US" sz="2550" dirty="0" spc="-1" kern="0">
                 <a:solidFill>
                   <a:srgbClr val="F3EEE3"/>
@@ -6272,10 +6305,10 @@
                 <a:ea typeface="Be Vietnam Pro" pitchFamily="34" charset="-122"/>
                 <a:cs typeface="Be Vietnam Pro" pitchFamily="34" charset="-120"/>
               </a:rPr>
-              <a:t>Mỗi</a:t>
-            </a:r>
-            <a:r>
-              <a:rPr lang="en-US" sz="2550" dirty="0" spc="-11" kern="0">
+              <a:t> ở</a:t>
+            </a:r>
+            <a:r>
+              <a:rPr lang="en-US" sz="2550" dirty="0" spc="0" kern="0">
                 <a:solidFill>
                   <a:srgbClr val="F3EEE3"/>
                 </a:solidFill>
@@ -6283,7 +6316,29 @@
                 <a:ea typeface="Be Vietnam Pro" pitchFamily="34" charset="-122"/>
                 <a:cs typeface="Be Vietnam Pro" pitchFamily="34" charset="-120"/>
               </a:rPr>
-              <a:t> tên</a:t>
+              <a:t> nhóm</a:t>
+            </a:r>
+            <a:r>
+              <a:rPr lang="en-US" sz="2550" dirty="0" spc="-10" kern="0">
+                <a:solidFill>
+                  <a:srgbClr val="F3EEE3"/>
+                </a:solidFill>
+                <a:latin typeface="Be Vietnam Pro" pitchFamily="34" charset="0"/>
+                <a:ea typeface="Be Vietnam Pro" pitchFamily="34" charset="-122"/>
+                <a:cs typeface="Be Vietnam Pro" pitchFamily="34" charset="-120"/>
+              </a:rPr>
+              <a:t> này</a:t>
+            </a:r>
+            <a:r>
+              <a:rPr lang="en-US" sz="2550" dirty="0" spc="15" kern="0">
+                <a:solidFill>
+                  <a:srgbClr val="F3EEE3"/>
+                </a:solidFill>
+                <a:latin typeface="Be Vietnam Pro" pitchFamily="34" charset="0"/>
+                <a:ea typeface="Be Vietnam Pro" pitchFamily="34" charset="-122"/>
+                <a:cs typeface="Be Vietnam Pro" pitchFamily="34" charset="-120"/>
+              </a:rPr>
+              <a:t> đều</a:t>
             </a:r>
             <a:r>
               <a:rPr lang="en-US" sz="2550" dirty="0" spc="0" kern="0">

</xml_diff>

<commit_message>
System Design vi: sd-10-024 SHA-256 64 ky tu thap luc phan o hinh, deck va PPTX
Co-Authored-By: Claude Sonnet 5.5 <noreply@anthropic.com>
Claude-Session: https://claude.ai/code/session_01JJCRKgpbfdpiPMwgBVozBY
</commit_message>
<xml_diff>
--- a/system-design-101/vi/lessons/sd-10-024/slides/sd-10-024.pptx
+++ b/system-design-101/vi/lessons/sd-10-024/slides/sd-10-024.pptx
@@ -10881,10 +10881,10 @@
                 <a:ea typeface="Be Vietnam Pro" pitchFamily="34" charset="-122"/>
                 <a:cs typeface="Be Vietnam Pro" pitchFamily="34" charset="-120"/>
               </a:rPr>
-              <a:t>SHA-256: luôn</a:t>
-            </a:r>
-            <a:r>
-              <a:rPr lang="en-US" sz="2700" dirty="0" spc="-40" kern="0">
+              <a:t>SHA-256:</a:t>
+            </a:r>
+            <a:r>
+              <a:rPr lang="en-US" sz="2700" dirty="0" spc="0" kern="0">
                 <a:solidFill>
                   <a:srgbClr val="F3EEE3"/>
                 </a:solidFill>
@@ -10892,7 +10892,29 @@
                 <a:ea typeface="Be Vietnam Pro" pitchFamily="34" charset="-122"/>
                 <a:cs typeface="Be Vietnam Pro" pitchFamily="34" charset="-120"/>
               </a:rPr>
-              <a:t> ra</a:t>
+              <a:t> 64</a:t>
+            </a:r>
+            <a:r>
+              <a:rPr lang="en-US" sz="2700" dirty="0" spc="-2" kern="0">
+                <a:solidFill>
+                  <a:srgbClr val="F3EEE3"/>
+                </a:solidFill>
+                <a:latin typeface="Be Vietnam Pro" pitchFamily="34" charset="0"/>
+                <a:ea typeface="Be Vietnam Pro" pitchFamily="34" charset="-122"/>
+                <a:cs typeface="Be Vietnam Pro" pitchFamily="34" charset="-120"/>
+              </a:rPr>
+              <a:t> ký</a:t>
+            </a:r>
+            <a:r>
+              <a:rPr lang="en-US" sz="2700" dirty="0" spc="-1" kern="0">
+                <a:solidFill>
+                  <a:srgbClr val="F3EEE3"/>
+                </a:solidFill>
+                <a:latin typeface="Be Vietnam Pro" pitchFamily="34" charset="0"/>
+                <a:ea typeface="Be Vietnam Pro" pitchFamily="34" charset="-122"/>
+                <a:cs typeface="Be Vietnam Pro" pitchFamily="34" charset="-120"/>
+              </a:rPr>
+              <a:t> tự</a:t>
             </a:r>
             <a:r>
               <a:rPr lang="en-US" sz="2700" dirty="0" spc="0" kern="0">
@@ -10903,7 +10925,18 @@
                 <a:ea typeface="Be Vietnam Pro" pitchFamily="34" charset="-122"/>
                 <a:cs typeface="Be Vietnam Pro" pitchFamily="34" charset="-120"/>
               </a:rPr>
-              <a:t> 64</a:t>
+              <a:t> thập</a:t>
+            </a:r>
+            <a:r>
+              <a:rPr lang="en-US" sz="2700" dirty="0" spc="-1" kern="0">
+                <a:solidFill>
+                  <a:srgbClr val="F3EEE3"/>
+                </a:solidFill>
+                <a:latin typeface="Be Vietnam Pro" pitchFamily="34" charset="0"/>
+                <a:ea typeface="Be Vietnam Pro" pitchFamily="34" charset="-122"/>
+                <a:cs typeface="Be Vietnam Pro" pitchFamily="34" charset="-120"/>
+              </a:rPr>
+              <a:t> lục</a:t>
             </a:r>
             <a:r>
               <a:rPr lang="en-US" sz="2700" dirty="0" spc="-2" kern="0">
@@ -10914,18 +10947,7 @@
                 <a:ea typeface="Be Vietnam Pro" pitchFamily="34" charset="-122"/>
                 <a:cs typeface="Be Vietnam Pro" pitchFamily="34" charset="-120"/>
               </a:rPr>
-              <a:t> ký</a:t>
-            </a:r>
-            <a:r>
-              <a:rPr lang="en-US" sz="2700" dirty="0" spc="-1" kern="0">
-                <a:solidFill>
-                  <a:srgbClr val="F3EEE3"/>
-                </a:solidFill>
-                <a:latin typeface="Be Vietnam Pro" pitchFamily="34" charset="0"/>
-                <a:ea typeface="Be Vietnam Pro" pitchFamily="34" charset="-122"/>
-                <a:cs typeface="Be Vietnam Pro" pitchFamily="34" charset="-120"/>
-              </a:rPr>
-              <a:t> tự.</a:t>
+              <a:t> phân.</a:t>
             </a:r>
             <a:endParaRPr lang="en-US" sz="2700" dirty="0"/>
           </a:p>
@@ -11742,6 +11764,17 @@
                 <a:cs typeface="Be Vietnam Pro" pitchFamily="34" charset="-120"/>
               </a:rPr>
               <a:t> tự</a:t>
+            </a:r>
+            <a:r>
+              <a:rPr lang="en-US" sz="2100" b="1" dirty="0" spc="-20" kern="0">
+                <a:solidFill>
+                  <a:srgbClr val="F3EEE3"/>
+                </a:solidFill>
+                <a:latin typeface="Be Vietnam Pro" pitchFamily="34" charset="0"/>
+                <a:ea typeface="Be Vietnam Pro" pitchFamily="34" charset="-122"/>
+                <a:cs typeface="Be Vietnam Pro" pitchFamily="34" charset="-120"/>
+              </a:rPr>
+              <a:t> hex</a:t>
             </a:r>
             <a:endParaRPr lang="en-US" sz="2100" dirty="0"/>
           </a:p>

</xml_diff>

<commit_message>
System Design vi: hinh sd-10-024, 025, 026 va deck sd-10-024 ghi dung pham vi thu nghiem
Co-Authored-By: Claude Sonnet 5.5 <noreply@anthropic.com>
Claude-Session: https://claude.ai/code/session_01JJCRKgpbfdpiPMwgBVozBY
</commit_message>
<xml_diff>
--- a/system-design-101/vi/lessons/sd-10-024/slides/sd-10-024.pptx
+++ b/system-design-101/vi/lessons/sd-10-024/slides/sd-10-024.pptx
@@ -4850,15 +4850,59 @@
               <a:buNone/>
             </a:pPr>
             <a:r>
-              <a:rPr lang="en-US" sz="2850" dirty="0" spc="-16" kern="0">
-                <a:solidFill>
-                  <a:srgbClr val="14161C"/>
-                </a:solidFill>
-                <a:latin typeface="Be Vietnam Pro" pitchFamily="34" charset="0"/>
-                <a:ea typeface="Be Vietnam Pro" pitchFamily="34" charset="-122"/>
-                <a:cs typeface="Be Vietnam Pro" pitchFamily="34" charset="-120"/>
-              </a:rPr>
-              <a:t>Bảy</a:t>
+              <a:rPr lang="en-US" sz="2850" dirty="0" spc="-1" kern="0">
+                <a:solidFill>
+                  <a:srgbClr val="14161C"/>
+                </a:solidFill>
+                <a:latin typeface="Be Vietnam Pro" pitchFamily="34" charset="0"/>
+                <a:ea typeface="Be Vietnam Pro" pitchFamily="34" charset="-122"/>
+                <a:cs typeface="Be Vietnam Pro" pitchFamily="34" charset="-120"/>
+              </a:rPr>
+              <a:t>Bài</a:t>
+            </a:r>
+            <a:r>
+              <a:rPr lang="en-US" sz="2850" dirty="0" spc="20" kern="0">
+                <a:solidFill>
+                  <a:srgbClr val="14161C"/>
+                </a:solidFill>
+                <a:latin typeface="Be Vietnam Pro" pitchFamily="34" charset="0"/>
+                <a:ea typeface="Be Vietnam Pro" pitchFamily="34" charset="-122"/>
+                <a:cs typeface="Be Vietnam Pro" pitchFamily="34" charset="-120"/>
+              </a:rPr>
+              <a:t> đã</a:t>
+            </a:r>
+            <a:r>
+              <a:rPr lang="en-US" sz="2850" dirty="0" spc="-9" kern="0">
+                <a:solidFill>
+                  <a:srgbClr val="14161C"/>
+                </a:solidFill>
+                <a:latin typeface="Be Vietnam Pro" pitchFamily="34" charset="0"/>
+                <a:ea typeface="Be Vietnam Pro" pitchFamily="34" charset="-122"/>
+                <a:cs typeface="Be Vietnam Pro" pitchFamily="34" charset="-120"/>
+              </a:rPr>
+              <a:t> chạy</a:t>
+            </a:r>
+            <a:r>
+              <a:rPr lang="en-US" sz="2850" dirty="0" spc="-1" kern="0">
+                <a:solidFill>
+                  <a:srgbClr val="14161C"/>
+                </a:solidFill>
+                <a:latin typeface="Be Vietnam Pro" pitchFamily="34" charset="0"/>
+                <a:ea typeface="Be Vietnam Pro" pitchFamily="34" charset="-122"/>
+                <a:cs typeface="Be Vietnam Pro" pitchFamily="34" charset="-120"/>
+              </a:rPr>
+              <a:t> thử</a:t>
+            </a:r>
+            <a:r>
+              <a:rPr lang="en-US" sz="2850" dirty="0" spc="-14" kern="0">
+                <a:solidFill>
+                  <a:srgbClr val="14161C"/>
+                </a:solidFill>
+                <a:latin typeface="Be Vietnam Pro" pitchFamily="34" charset="0"/>
+                <a:ea typeface="Be Vietnam Pro" pitchFamily="34" charset="-122"/>
+                <a:cs typeface="Be Vietnam Pro" pitchFamily="34" charset="-120"/>
+              </a:rPr>
+              <a:t> bảy</a:t>
             </a:r>
             <a:r>
               <a:rPr lang="en-US" sz="2850" dirty="0" spc="-19" kern="0">
@@ -4883,7 +4927,7 @@
               <a:t> chín</a:t>
             </a:r>
             <a:r>
-              <a:rPr lang="en-US" sz="2850" dirty="0" spc="-11" kern="0">
+              <a:rPr lang="en-US" sz="2850" dirty="0" spc="-10" kern="0">
                 <a:solidFill>
                   <a:srgbClr val="14161C"/>
                 </a:solidFill>
@@ -4894,81 +4938,15 @@
               <a:t> thuật</a:t>
             </a:r>
             <a:r>
-              <a:rPr lang="en-US" sz="2850" dirty="0" spc="-14" kern="0">
-                <a:solidFill>
-                  <a:srgbClr val="14161C"/>
-                </a:solidFill>
-                <a:latin typeface="Be Vietnam Pro" pitchFamily="34" charset="0"/>
-                <a:ea typeface="Be Vietnam Pro" pitchFamily="34" charset="-122"/>
-                <a:cs typeface="Be Vietnam Pro" pitchFamily="34" charset="-120"/>
-              </a:rPr>
-              <a:t> toán</a:t>
-            </a:r>
-            <a:r>
-              <a:rPr lang="en-US" sz="2850" dirty="0" spc="-1" kern="0">
-                <a:solidFill>
-                  <a:srgbClr val="14161C"/>
-                </a:solidFill>
-                <a:latin typeface="Be Vietnam Pro" pitchFamily="34" charset="0"/>
-                <a:ea typeface="Be Vietnam Pro" pitchFamily="34" charset="-122"/>
-                <a:cs typeface="Be Vietnam Pro" pitchFamily="34" charset="-120"/>
-              </a:rPr>
-              <a:t> thử</a:t>
-            </a:r>
-            <a:r>
-              <a:rPr lang="en-US" sz="2850" dirty="0" spc="9" kern="0">
-                <a:solidFill>
-                  <a:srgbClr val="14161C"/>
-                </a:solidFill>
-                <a:latin typeface="Be Vietnam Pro" pitchFamily="34" charset="0"/>
-                <a:ea typeface="Be Vietnam Pro" pitchFamily="34" charset="-122"/>
-                <a:cs typeface="Be Vietnam Pro" pitchFamily="34" charset="-120"/>
-              </a:rPr>
-              <a:t> được</a:t>
-            </a:r>
-            <a:r>
-              <a:rPr lang="en-US" sz="2850" dirty="0" spc="-5" kern="0">
-                <a:solidFill>
-                  <a:srgbClr val="14161C"/>
-                </a:solidFill>
-                <a:latin typeface="Be Vietnam Pro" pitchFamily="34" charset="0"/>
-                <a:ea typeface="Be Vietnam Pro" pitchFamily="34" charset="-122"/>
-                <a:cs typeface="Be Vietnam Pro" pitchFamily="34" charset="-120"/>
-              </a:rPr>
-              <a:t> bằng</a:t>
-            </a:r>
-            <a:r>
-              <a:rPr lang="en-US" sz="2850" dirty="0" spc="-11" kern="0">
-                <a:solidFill>
-                  <a:srgbClr val="14161C"/>
-                </a:solidFill>
-                <a:latin typeface="Be Vietnam Pro" pitchFamily="34" charset="0"/>
-                <a:ea typeface="Be Vietnam Pro" pitchFamily="34" charset="-122"/>
-                <a:cs typeface="Be Vietnam Pro" pitchFamily="34" charset="-120"/>
-              </a:rPr>
-              <a:t> vài</a:t>
-            </a:r>
-            <a:r>
-              <a:rPr lang="en-US" sz="2850" dirty="0" spc="-3" kern="0">
-                <a:solidFill>
-                  <a:srgbClr val="14161C"/>
-                </a:solidFill>
-                <a:latin typeface="Be Vietnam Pro" pitchFamily="34" charset="0"/>
-                <a:ea typeface="Be Vietnam Pro" pitchFamily="34" charset="-122"/>
-                <a:cs typeface="Be Vietnam Pro" pitchFamily="34" charset="-120"/>
-              </a:rPr>
-              <a:t> dòng</a:t>
-            </a:r>
-            <a:r>
-              <a:rPr lang="en-US" sz="2850" dirty="0" spc="1" kern="0">
-                <a:solidFill>
-                  <a:srgbClr val="14161C"/>
-                </a:solidFill>
-                <a:latin typeface="Be Vietnam Pro" pitchFamily="34" charset="0"/>
-                <a:ea typeface="Be Vietnam Pro" pitchFamily="34" charset="-122"/>
-                <a:cs typeface="Be Vietnam Pro" pitchFamily="34" charset="-120"/>
-              </a:rPr>
-              <a:t> mã.</a:t>
+              <a:rPr lang="en-US" sz="2850" dirty="0" spc="-12" kern="0">
+                <a:solidFill>
+                  <a:srgbClr val="14161C"/>
+                </a:solidFill>
+                <a:latin typeface="Be Vietnam Pro" pitchFamily="34" charset="0"/>
+                <a:ea typeface="Be Vietnam Pro" pitchFamily="34" charset="-122"/>
+                <a:cs typeface="Be Vietnam Pro" pitchFamily="34" charset="-120"/>
+              </a:rPr>
+              <a:t> toán.</a:t>
             </a:r>
             <a:endParaRPr lang="en-US" sz="2850" dirty="0"/>
           </a:p>

</xml_diff>